<commit_message>
Publish hosted report presentation and clean release manifest
</commit_message>
<xml_diff>
--- a/docs/presentation/MyBud_Student_Life_Assistant.pptx
+++ b/docs/presentation/MyBud_Student_Life_Assistant.pptx
@@ -2,22 +2,22 @@
 <file path=ppt/presentation.xml><?xml version="1.0" encoding="utf-8"?>
 <p:presentation xmlns:p="http://schemas.openxmlformats.org/presentationml/2006/main">
   <p:sldMasterIdLst>
-    <p:sldMasterId xmlns:r="http://schemas.openxmlformats.org/officeDocument/2006/relationships" id="2147483648" r:id="R93a722d271f447ee"/>
+    <p:sldMasterId xmlns:r="http://schemas.openxmlformats.org/officeDocument/2006/relationships" id="2147483648" r:id="R0c8be0c3d09543c0"/>
   </p:sldMasterIdLst>
   <p:notesMasterIdLst>
-    <p:notesMasterId xmlns:r="http://schemas.openxmlformats.org/officeDocument/2006/relationships" r:id="Rf5a0be091d914938"/>
+    <p:notesMasterId xmlns:r="http://schemas.openxmlformats.org/officeDocument/2006/relationships" r:id="Rb5c31f399bc740d5"/>
   </p:notesMasterIdLst>
   <p:sldIdLst>
-    <p:sldId xmlns:r="http://schemas.openxmlformats.org/officeDocument/2006/relationships" id="256" r:id="Ra09c954215f341bd"/>
-    <p:sldId xmlns:r="http://schemas.openxmlformats.org/officeDocument/2006/relationships" id="257" r:id="R7f5e69690665404f"/>
-    <p:sldId xmlns:r="http://schemas.openxmlformats.org/officeDocument/2006/relationships" id="258" r:id="R0a869e751482489a"/>
-    <p:sldId xmlns:r="http://schemas.openxmlformats.org/officeDocument/2006/relationships" id="259" r:id="Rb7a2a58ec5fb416c"/>
-    <p:sldId xmlns:r="http://schemas.openxmlformats.org/officeDocument/2006/relationships" id="260" r:id="Rde2b4cbe00ff4df8"/>
-    <p:sldId xmlns:r="http://schemas.openxmlformats.org/officeDocument/2006/relationships" id="261" r:id="R396f115fb71341f7"/>
-    <p:sldId xmlns:r="http://schemas.openxmlformats.org/officeDocument/2006/relationships" id="262" r:id="R19b11bc51a1b4553"/>
-    <p:sldId xmlns:r="http://schemas.openxmlformats.org/officeDocument/2006/relationships" id="263" r:id="R02c9e7bee02f4d57"/>
-    <p:sldId xmlns:r="http://schemas.openxmlformats.org/officeDocument/2006/relationships" id="264" r:id="Rdcf403a4686f4d61"/>
-    <p:sldId xmlns:r="http://schemas.openxmlformats.org/officeDocument/2006/relationships" id="265" r:id="R999a5082c1064fa4"/>
+    <p:sldId xmlns:r="http://schemas.openxmlformats.org/officeDocument/2006/relationships" id="256" r:id="R7a7a683ab02742d1"/>
+    <p:sldId xmlns:r="http://schemas.openxmlformats.org/officeDocument/2006/relationships" id="257" r:id="R4978b1b1216b4b1c"/>
+    <p:sldId xmlns:r="http://schemas.openxmlformats.org/officeDocument/2006/relationships" id="258" r:id="R4ad65ac87192488c"/>
+    <p:sldId xmlns:r="http://schemas.openxmlformats.org/officeDocument/2006/relationships" id="259" r:id="R3999001b5db24322"/>
+    <p:sldId xmlns:r="http://schemas.openxmlformats.org/officeDocument/2006/relationships" id="260" r:id="R35ee55afb20a4058"/>
+    <p:sldId xmlns:r="http://schemas.openxmlformats.org/officeDocument/2006/relationships" id="261" r:id="R11201a13f9064f0a"/>
+    <p:sldId xmlns:r="http://schemas.openxmlformats.org/officeDocument/2006/relationships" id="262" r:id="R44850011a23a4be3"/>
+    <p:sldId xmlns:r="http://schemas.openxmlformats.org/officeDocument/2006/relationships" id="263" r:id="Rb80e907471944249"/>
+    <p:sldId xmlns:r="http://schemas.openxmlformats.org/officeDocument/2006/relationships" id="264" r:id="R460b66579fc14d90"/>
+    <p:sldId xmlns:r="http://schemas.openxmlformats.org/officeDocument/2006/relationships" id="265" r:id="R7217087d06c4425c"/>
   </p:sldIdLst>
   <p:sldSz cx="12192000" cy="6858000"/>
   <p:notesSz cx="6858000" cy="9144000"/>
@@ -451,7 +451,7 @@
           <a:lstStyle xmlns:a="http://schemas.openxmlformats.org/drawingml/2006/main"/>
           <a:p xmlns:a="http://schemas.openxmlformats.org/drawingml/2006/main">
             <a:r>
-              <a:t>MyBud is a Django student assistant maintained by Bikash Kushwaha. The project combines chat, code review, recipe suggestions, travel itineraries, and a session-based expense tracker. Its default AI experience uses disclosed canned samples. Live Gemini requests are optional and require configuration.</a:t>
+              <a:t>MyBud is a Django student assistant maintained by Bikash Kushwaha. The public demo uses Vercel native Django in Singapore and Neon PostgreSQL. Its assistant experience uses disclosed canned samples, local Python syntax parsing and image validation; no live Gemini requests run. Live Gemini is optional.</a:t>
             </a:r>
           </a:p>
           <a:p xmlns:a="http://schemas.openxmlformats.org/drawingml/2006/main">
@@ -472,6 +472,16 @@
           <a:p xmlns:a="http://schemas.openxmlformats.org/drawingml/2006/main">
             <a:r>
               <a:t>SOURCE_ACKNOWLEDGEMENTS.md</a:t>
+            </a:r>
+          </a:p>
+          <a:p xmlns:a="http://schemas.openxmlformats.org/drawingml/2006/main">
+            <a:r>
+              <a:t>https://github.com/BikashCoder31/mybud-student-assistant</a:t>
+            </a:r>
+          </a:p>
+          <a:p xmlns:a="http://schemas.openxmlformats.org/drawingml/2006/main">
+            <a:r>
+              <a:t>https://mybud-student-assistant.vercel.app</a:t>
             </a:r>
           </a:p>
         </p:txBody>
@@ -736,7 +746,7 @@
           <a:lstStyle xmlns:a="http://schemas.openxmlformats.org/drawingml/2006/main"/>
           <a:p xmlns:a="http://schemas.openxmlformats.org/drawingml/2006/main">
             <a:r>
-              <a:t>The browser renders Django templates and calls the application endpoints. Views validate input and dispatch assistant tasks through the configured provider. Expense records and monthly budget values are owned by a Django session key and persisted in SQLite. The diagram represents the local demonstration deployment, not a multi-user production architecture.</a:t>
+              <a:t>Django validates browser requests and dispatches assistant tasks through the provider. A session key owns expense and budget records. Production uses Vercel native Django in Singapore and Neon PostgreSQL through a pooled TLS DATABASE_URL; migrations used a direct connection. Local development defaults to SQLite. Secrets stay on the server and mutating requests require CSRF protection.</a:t>
             </a:r>
           </a:p>
           <a:p xmlns:a="http://schemas.openxmlformats.org/drawingml/2006/main">
@@ -772,6 +782,11 @@
           <a:p xmlns:a="http://schemas.openxmlformats.org/drawingml/2006/main">
             <a:r>
               <a:t>main/models.py</a:t>
+            </a:r>
+          </a:p>
+          <a:p xmlns:a="http://schemas.openxmlformats.org/drawingml/2006/main">
+            <a:r>
+              <a:t>docs/DEPLOYMENT.md</a:t>
             </a:r>
           </a:p>
         </p:txBody>
@@ -1036,7 +1051,7 @@
           <a:lstStyle xmlns:a="http://schemas.openxmlformats.org/drawingml/2006/main"/>
           <a:p xmlns:a="http://schemas.openxmlformats.org/drawingml/2006/main">
             <a:r>
-              <a:t>These screenshots show actual tool results from local sample mode. The recipe endpoint accepts an optional image and validates supported content and size. A sample result does not imply that image contents were inferred. The travel tool renders an itinerary using the supplied trip details.</a:t>
+              <a:t>These screenshots are captured application evidence from local demo mode. Hosted mode uses the same templates, with a 3 MB image cap compared with the local default of 5 MB. Images are validated, not classified, in demo mode. The travel tool renders an itinerary using supplied trip details.</a:t>
             </a:r>
           </a:p>
           <a:p xmlns:a="http://schemas.openxmlformats.org/drawingml/2006/main">
@@ -1136,7 +1151,7 @@
           <a:lstStyle xmlns:a="http://schemas.openxmlformats.org/drawingml/2006/main"/>
           <a:p xmlns:a="http://schemas.openxmlformats.org/drawingml/2006/main">
             <a:r>
-              <a:t>The native table transcribes the captured demonstration: Meals NPR 250.25, Books NPR 400.00, Transport NPR 150.00; total NPR 800.25 against budget NPR 1000.00, leaving NPR 199.75. The tracker saves expense records and monthly budget data in SQLite. Views restrict records to the current Django session. This provides browser-session isolation for the local demonstration; it is not account authentication. Deleting a browser session loses access to its prior records.</a:t>
+              <a:t>The native table transcribes captured local demonstration entries: Meals NPR 250.25, Books NPR 400.00, Transport NPR 150.00; total NPR 800.25 against budget NPR 1000.00, leaving NPR 199.75. Production stores records in Neon PostgreSQL; local mode uses SQLite. The same session ownership rules apply. Losing a browser session loses access to its prior records.</a:t>
             </a:r>
           </a:p>
           <a:p xmlns:a="http://schemas.openxmlformats.org/drawingml/2006/main">
@@ -1236,7 +1251,7 @@
           <a:lstStyle xmlns:a="http://schemas.openxmlformats.org/drawingml/2006/main"/>
           <a:p xmlns:a="http://schemas.openxmlformats.org/drawingml/2006/main">
             <a:r>
-              <a:t>Verification statements are transcribed from the final project verification record. Automated tests and browser checks establish the documented local behavior. They do not provide model quality metrics, usability-study results, or production load measurements.</a:t>
+              <a:t>28 tests passed locally and in GitHub Actions run 39472651723 for commit 7d7b1de, including Ruff lint and format checks. Public Edge QA covered all five tools, actual image upload, expense budget/add/reload/delete, session isolation, HTML injection, and six routes at desktop1440x1000/mobile390x844 with no console issues or failed requests. No live Gemini or camera hardware tests were run. No load or model quality claim is made.</a:t>
             </a:r>
           </a:p>
           <a:p xmlns:a="http://schemas.openxmlformats.org/drawingml/2006/main">
@@ -1262,6 +1277,11 @@
           <a:p xmlns:a="http://schemas.openxmlformats.org/drawingml/2006/main">
             <a:r>
               <a:t>docs/screenshots/</a:t>
+            </a:r>
+          </a:p>
+          <a:p xmlns:a="http://schemas.openxmlformats.org/drawingml/2006/main">
+            <a:r>
+              <a:t>https://github.com/BikashCoder31/mybud-student-assistant/actions/runs/39472651723</a:t>
             </a:r>
           </a:p>
         </p:txBody>
@@ -1413,7 +1433,7 @@
           <p:cNvPr id="3" name="Title">
             <a:extLst xmlns:a="http://schemas.openxmlformats.org/drawingml/2006/main">
               <a:ext uri="{FF2B5EF4-FFF2-40B4-BE49-F238E27FC236}">
-                <a16:creationId xmlns:a16="http://schemas.microsoft.com/office/drawing/2014/main" id="{5B058F79-ADAB-4A15-B591-EAC0E1A5C242}"/>
+                <a16:creationId xmlns:a16="http://schemas.microsoft.com/office/drawing/2014/main" id="{0FC0A0C2-DA85-44BE-8A40-57186896ACD3}"/>
               </a:ext>
             </a:extLst>
           </p:cNvPr>
@@ -1642,7 +1662,7 @@
           <p:cNvPr id="2" name="Subtitle">
             <a:extLst xmlns:a="http://schemas.openxmlformats.org/drawingml/2006/main">
               <a:ext uri="{FF2B5EF4-FFF2-40B4-BE49-F238E27FC236}">
-                <a16:creationId xmlns:a16="http://schemas.microsoft.com/office/drawing/2014/main" id="{D5EBF735-7A65-4C80-AD06-DF03A62E1732}"/>
+                <a16:creationId xmlns:a16="http://schemas.microsoft.com/office/drawing/2014/main" id="{5E802534-67E6-48B6-A982-544EEE7B1F32}"/>
               </a:ext>
             </a:extLst>
           </p:cNvPr>
@@ -1888,7 +1908,7 @@
           <p:cNvPr id="2" name="Section title">
             <a:extLst xmlns:a="http://schemas.openxmlformats.org/drawingml/2006/main">
               <a:ext uri="{FF2B5EF4-FFF2-40B4-BE49-F238E27FC236}">
-                <a16:creationId xmlns:a16="http://schemas.microsoft.com/office/drawing/2014/main" id="{078AAA26-3F2C-4F79-9943-79EAC0D106A3}"/>
+                <a16:creationId xmlns:a16="http://schemas.microsoft.com/office/drawing/2014/main" id="{469223A0-9016-4995-B4D7-E87CD3C0AFB0}"/>
               </a:ext>
             </a:extLst>
           </p:cNvPr>
@@ -2134,7 +2154,7 @@
           <p:cNvPr id="3" name="Title">
             <a:extLst xmlns:a="http://schemas.openxmlformats.org/drawingml/2006/main">
               <a:ext uri="{FF2B5EF4-FFF2-40B4-BE49-F238E27FC236}">
-                <a16:creationId xmlns:a16="http://schemas.microsoft.com/office/drawing/2014/main" id="{FE42F5C0-11A1-45CD-9150-F2AAE997A627}"/>
+                <a16:creationId xmlns:a16="http://schemas.microsoft.com/office/drawing/2014/main" id="{F339959D-784F-459B-9254-31AFFFEAA905}"/>
               </a:ext>
             </a:extLst>
           </p:cNvPr>
@@ -2363,7 +2383,7 @@
           <p:cNvPr id="2" name="Body">
             <a:extLst xmlns:a="http://schemas.openxmlformats.org/drawingml/2006/main">
               <a:ext uri="{FF2B5EF4-FFF2-40B4-BE49-F238E27FC236}">
-                <a16:creationId xmlns:a16="http://schemas.microsoft.com/office/drawing/2014/main" id="{088CB104-9290-483A-995A-D42A0BA1E8FF}"/>
+                <a16:creationId xmlns:a16="http://schemas.microsoft.com/office/drawing/2014/main" id="{5384292A-DA9E-42F6-99C3-83D7D8344417}"/>
               </a:ext>
             </a:extLst>
           </p:cNvPr>
@@ -2609,7 +2629,7 @@
           <p:cNvPr id="4" name="Title">
             <a:extLst xmlns:a="http://schemas.openxmlformats.org/drawingml/2006/main">
               <a:ext uri="{FF2B5EF4-FFF2-40B4-BE49-F238E27FC236}">
-                <a16:creationId xmlns:a16="http://schemas.microsoft.com/office/drawing/2014/main" id="{F7682F6D-839E-48A7-B42E-892B7C457A74}"/>
+                <a16:creationId xmlns:a16="http://schemas.microsoft.com/office/drawing/2014/main" id="{74730D99-9194-420B-B014-5C7DE13D8FF6}"/>
               </a:ext>
             </a:extLst>
           </p:cNvPr>
@@ -2838,7 +2858,7 @@
           <p:cNvPr id="2" name="Left column">
             <a:extLst xmlns:a="http://schemas.openxmlformats.org/drawingml/2006/main">
               <a:ext uri="{FF2B5EF4-FFF2-40B4-BE49-F238E27FC236}">
-                <a16:creationId xmlns:a16="http://schemas.microsoft.com/office/drawing/2014/main" id="{B0BEB87B-9019-45EC-BE71-117A51515F74}"/>
+                <a16:creationId xmlns:a16="http://schemas.microsoft.com/office/drawing/2014/main" id="{3FEB917E-9FB0-4313-9C6B-E46F45AD156F}"/>
               </a:ext>
             </a:extLst>
           </p:cNvPr>
@@ -3067,7 +3087,7 @@
           <p:cNvPr id="3" name="Right column">
             <a:extLst xmlns:a="http://schemas.openxmlformats.org/drawingml/2006/main">
               <a:ext uri="{FF2B5EF4-FFF2-40B4-BE49-F238E27FC236}">
-                <a16:creationId xmlns:a16="http://schemas.microsoft.com/office/drawing/2014/main" id="{44DBE23B-F91A-4E84-95FB-C4E5F60528BD}"/>
+                <a16:creationId xmlns:a16="http://schemas.microsoft.com/office/drawing/2014/main" id="{BF589261-D633-4398-98A4-D7C493396FAA}"/>
               </a:ext>
             </a:extLst>
           </p:cNvPr>
@@ -3313,7 +3333,7 @@
           <p:cNvPr id="3" name="Title">
             <a:extLst xmlns:a="http://schemas.openxmlformats.org/drawingml/2006/main">
               <a:ext uri="{FF2B5EF4-FFF2-40B4-BE49-F238E27FC236}">
-                <a16:creationId xmlns:a16="http://schemas.microsoft.com/office/drawing/2014/main" id="{15836F42-042B-461A-B3C8-6FEF69326EAB}"/>
+                <a16:creationId xmlns:a16="http://schemas.microsoft.com/office/drawing/2014/main" id="{C0E9124F-D4AC-498B-82DF-1C5B7CD9E5E0}"/>
               </a:ext>
             </a:extLst>
           </p:cNvPr>
@@ -3542,7 +3562,7 @@
           <p:cNvPr id="2" name="Left column">
             <a:extLst xmlns:a="http://schemas.openxmlformats.org/drawingml/2006/main">
               <a:ext uri="{FF2B5EF4-FFF2-40B4-BE49-F238E27FC236}">
-                <a16:creationId xmlns:a16="http://schemas.microsoft.com/office/drawing/2014/main" id="{EF3E1104-FB6E-4B0B-B3BF-290A0C2D0FBF}"/>
+                <a16:creationId xmlns:a16="http://schemas.microsoft.com/office/drawing/2014/main" id="{E1C0BC44-E4EF-47FC-95F7-3102338BA9A2}"/>
               </a:ext>
             </a:extLst>
           </p:cNvPr>
@@ -3809,12 +3829,12 @@
   </p:cSld>
   <p:clrMap bg1="lt1" tx1="dk1" bg2="lt2" tx2="dk2" accent1="accent1" accent2="accent2" accent3="accent3" accent4="accent4" accent5="accent5" accent6="accent6" hlink="hlink" folHlink="folHlink"/>
   <p:sldLayoutIdLst>
-    <p:sldLayoutId xmlns:r="http://schemas.openxmlformats.org/officeDocument/2006/relationships" id="2147483649" r:id="R45aa01329c3046e0"/>
-    <p:sldLayoutId xmlns:r="http://schemas.openxmlformats.org/officeDocument/2006/relationships" id="2147483650" r:id="Rd38dd5418a4b4921"/>
-    <p:sldLayoutId xmlns:r="http://schemas.openxmlformats.org/officeDocument/2006/relationships" id="2147483651" r:id="R9d4f1578f50e4203"/>
-    <p:sldLayoutId xmlns:r="http://schemas.openxmlformats.org/officeDocument/2006/relationships" id="2147483652" r:id="R304013d768c04da0"/>
-    <p:sldLayoutId xmlns:r="http://schemas.openxmlformats.org/officeDocument/2006/relationships" id="2147483653" r:id="R77d9003937d94258"/>
-    <p:sldLayoutId xmlns:r="http://schemas.openxmlformats.org/officeDocument/2006/relationships" id="2147483654" r:id="R02c8e3bdc9b142c6"/>
+    <p:sldLayoutId xmlns:r="http://schemas.openxmlformats.org/officeDocument/2006/relationships" id="2147483649" r:id="Rb847f0e4eebf4bce"/>
+    <p:sldLayoutId xmlns:r="http://schemas.openxmlformats.org/officeDocument/2006/relationships" id="2147483650" r:id="Ref8686a58d954a23"/>
+    <p:sldLayoutId xmlns:r="http://schemas.openxmlformats.org/officeDocument/2006/relationships" id="2147483651" r:id="R3baaba3e397245c9"/>
+    <p:sldLayoutId xmlns:r="http://schemas.openxmlformats.org/officeDocument/2006/relationships" id="2147483652" r:id="R99368e269e6f4e5b"/>
+    <p:sldLayoutId xmlns:r="http://schemas.openxmlformats.org/officeDocument/2006/relationships" id="2147483653" r:id="Re3075aaf7cc34b6b"/>
+    <p:sldLayoutId xmlns:r="http://schemas.openxmlformats.org/officeDocument/2006/relationships" id="2147483654" r:id="Rcaae490f77894d4b"/>
   </p:sldLayoutIdLst>
   <p:txStyles>
     <p:titleStyle>
@@ -4365,7 +4385,7 @@
           <p:cNvPr id="6" name="cover-accent">
             <a:extLst xmlns:a="http://schemas.openxmlformats.org/drawingml/2006/main">
               <a:ext uri="{FF2B5EF4-FFF2-40B4-BE49-F238E27FC236}">
-                <a16:creationId xmlns:a16="http://schemas.microsoft.com/office/drawing/2014/main" id="{DF693224-4668-40A4-B69C-1E87ABBCBC9E}"/>
+                <a16:creationId xmlns:a16="http://schemas.microsoft.com/office/drawing/2014/main" id="{19D9F44A-44B0-4BFE-B450-4C364513C641}"/>
               </a:ext>
             </a:extLst>
           </p:cNvPr>
@@ -4395,7 +4415,7 @@
           <p:cNvPr id="2" name="cover-title">
             <a:extLst xmlns:a="http://schemas.openxmlformats.org/drawingml/2006/main">
               <a:ext uri="{FF2B5EF4-FFF2-40B4-BE49-F238E27FC236}">
-                <a16:creationId xmlns:a16="http://schemas.microsoft.com/office/drawing/2014/main" id="{D6C46861-97C4-4A4E-9839-7548DF54D44D}"/>
+                <a16:creationId xmlns:a16="http://schemas.microsoft.com/office/drawing/2014/main" id="{6F7CB5B2-E4DB-43E3-BF35-BFB9DB615B6A}"/>
               </a:ext>
             </a:extLst>
           </p:cNvPr>
@@ -4576,7 +4596,7 @@
           <p:cNvPr id="3" name="cover-description">
             <a:extLst xmlns:a="http://schemas.openxmlformats.org/drawingml/2006/main">
               <a:ext uri="{FF2B5EF4-FFF2-40B4-BE49-F238E27FC236}">
-                <a16:creationId xmlns:a16="http://schemas.microsoft.com/office/drawing/2014/main" id="{D84464A3-CEF2-4179-B175-1E1F6BA5AEBF}"/>
+                <a16:creationId xmlns:a16="http://schemas.microsoft.com/office/drawing/2014/main" id="{1CC1BFB4-86DA-4746-8259-7468F698F8ED}"/>
               </a:ext>
             </a:extLst>
           </p:cNvPr>
@@ -4734,7 +4754,7 @@
           <p:cNvPr id="4" name="cover-author">
             <a:extLst xmlns:a="http://schemas.openxmlformats.org/drawingml/2006/main">
               <a:ext uri="{FF2B5EF4-FFF2-40B4-BE49-F238E27FC236}">
-                <a16:creationId xmlns:a16="http://schemas.microsoft.com/office/drawing/2014/main" id="{5A4DA2A3-A164-4A3A-A508-6E09DDA92E27}"/>
+                <a16:creationId xmlns:a16="http://schemas.microsoft.com/office/drawing/2014/main" id="{F1E6DB03-ED9E-43A4-9860-7FABE36BEF15}"/>
               </a:ext>
             </a:extLst>
           </p:cNvPr>
@@ -4892,7 +4912,7 @@
           <p:cNvPr id="5" name="cover-scope">
             <a:extLst xmlns:a="http://schemas.openxmlformats.org/drawingml/2006/main">
               <a:ext uri="{FF2B5EF4-FFF2-40B4-BE49-F238E27FC236}">
-                <a16:creationId xmlns:a16="http://schemas.microsoft.com/office/drawing/2014/main" id="{03485DC2-4E42-47D7-BC03-D424EBD2125D}"/>
+                <a16:creationId xmlns:a16="http://schemas.microsoft.com/office/drawing/2014/main" id="{C0FB8D61-D435-49B2-BD63-47EFD3A18311}"/>
               </a:ext>
             </a:extLst>
           </p:cNvPr>
@@ -5040,7 +5060,7 @@
                 <a:ea typeface="Arial"/>
                 <a:cs typeface="Arial"/>
               </a:rPr>
-              <a:t>Technical project presentation  |  October 2026</a:t>
+              <a:t>Hosted portfolio edition  |  October 2026</a:t>
             </a:r>
           </a:p>
         </p:txBody>
@@ -5048,7 +5068,7 @@
     </p:spTree>
     <p:extLst>
       <p:ext uri="{BB962C8B-B14F-4D97-AF65-F5344CB8AC3E}">
-        <p14:creationId xmlns:p14="http://schemas.microsoft.com/office/powerpoint/2010/main" val="1645879332"/>
+        <p14:creationId xmlns:p14="http://schemas.microsoft.com/office/powerpoint/2010/main" val="627334133"/>
       </p:ext>
     </p:extLst>
   </p:cSld>
@@ -5079,7 +5099,7 @@
           <p:cNvPr id="9" name="accent">
             <a:extLst xmlns:a="http://schemas.openxmlformats.org/drawingml/2006/main">
               <a:ext uri="{FF2B5EF4-FFF2-40B4-BE49-F238E27FC236}">
-                <a16:creationId xmlns:a16="http://schemas.microsoft.com/office/drawing/2014/main" id="{34C3F143-20D7-4C1A-AF54-5FBEA2ABE35C}"/>
+                <a16:creationId xmlns:a16="http://schemas.microsoft.com/office/drawing/2014/main" id="{F5520752-2999-4D34-951F-5992C72DB435}"/>
               </a:ext>
             </a:extLst>
           </p:cNvPr>
@@ -5109,7 +5129,7 @@
           <p:cNvPr id="2" name="title">
             <a:extLst xmlns:a="http://schemas.openxmlformats.org/drawingml/2006/main">
               <a:ext uri="{FF2B5EF4-FFF2-40B4-BE49-F238E27FC236}">
-                <a16:creationId xmlns:a16="http://schemas.microsoft.com/office/drawing/2014/main" id="{1B19F823-A8A5-44E6-9908-2CC6163FAB69}"/>
+                <a16:creationId xmlns:a16="http://schemas.microsoft.com/office/drawing/2014/main" id="{971B612E-AF71-4168-9686-58EEF7F59849}"/>
               </a:ext>
             </a:extLst>
           </p:cNvPr>
@@ -5267,7 +5287,7 @@
           <p:cNvPr id="3" name="number">
             <a:extLst xmlns:a="http://schemas.openxmlformats.org/drawingml/2006/main">
               <a:ext uri="{FF2B5EF4-FFF2-40B4-BE49-F238E27FC236}">
-                <a16:creationId xmlns:a16="http://schemas.microsoft.com/office/drawing/2014/main" id="{C775E831-1C57-4FD5-BB79-5D47B9501D98}"/>
+                <a16:creationId xmlns:a16="http://schemas.microsoft.com/office/drawing/2014/main" id="{1B0E79C5-A787-4A44-9CC2-7E5BEFB7BE42}"/>
               </a:ext>
             </a:extLst>
           </p:cNvPr>
@@ -5425,7 +5445,7 @@
           <p:cNvPr id="4" name="limits-heading">
             <a:extLst xmlns:a="http://schemas.openxmlformats.org/drawingml/2006/main">
               <a:ext uri="{FF2B5EF4-FFF2-40B4-BE49-F238E27FC236}">
-                <a16:creationId xmlns:a16="http://schemas.microsoft.com/office/drawing/2014/main" id="{82DA0545-77C9-46B3-B0AD-48A8B79A422E}"/>
+                <a16:creationId xmlns:a16="http://schemas.microsoft.com/office/drawing/2014/main" id="{E5FB6DB6-D3AC-4CFE-9DF5-856370E95180}"/>
               </a:ext>
             </a:extLst>
           </p:cNvPr>
@@ -5583,7 +5603,7 @@
           <p:cNvPr id="5" name="limits">
             <a:extLst xmlns:a="http://schemas.openxmlformats.org/drawingml/2006/main">
               <a:ext uri="{FF2B5EF4-FFF2-40B4-BE49-F238E27FC236}">
-                <a16:creationId xmlns:a16="http://schemas.microsoft.com/office/drawing/2014/main" id="{669EE3F3-5C9F-4471-B8CF-4B82B7513662}"/>
+                <a16:creationId xmlns:a16="http://schemas.microsoft.com/office/drawing/2014/main" id="{5F113DB9-0983-4597-AE8E-FFA749232276}"/>
               </a:ext>
             </a:extLst>
           </p:cNvPr>
@@ -5815,7 +5835,7 @@
                 <a:ea typeface="Arial"/>
                 <a:cs typeface="Arial"/>
               </a:rPr>
-              <a:t>SQLite suits the local demonstration.</a:t>
+              <a:t>Neon free-tier resource limits apply.</a:t>
             </a:r>
           </a:p>
         </p:txBody>
@@ -5825,7 +5845,7 @@
           <p:cNvPr id="6" name="next-heading">
             <a:extLst xmlns:a="http://schemas.openxmlformats.org/drawingml/2006/main">
               <a:ext uri="{FF2B5EF4-FFF2-40B4-BE49-F238E27FC236}">
-                <a16:creationId xmlns:a16="http://schemas.microsoft.com/office/drawing/2014/main" id="{E05D8222-0E49-4851-A403-4ECCA66152A9}"/>
+                <a16:creationId xmlns:a16="http://schemas.microsoft.com/office/drawing/2014/main" id="{E9433C61-F457-4C05-B1E8-5E0FC0E7E8B4}"/>
               </a:ext>
             </a:extLst>
           </p:cNvPr>
@@ -5983,7 +6003,7 @@
           <p:cNvPr id="7" name="next">
             <a:extLst xmlns:a="http://schemas.openxmlformats.org/drawingml/2006/main">
               <a:ext uri="{FF2B5EF4-FFF2-40B4-BE49-F238E27FC236}">
-                <a16:creationId xmlns:a16="http://schemas.microsoft.com/office/drawing/2014/main" id="{C24E5BB3-84D2-4732-9133-52C7A06CAF03}"/>
+                <a16:creationId xmlns:a16="http://schemas.microsoft.com/office/drawing/2014/main" id="{55ACE36E-42C4-4601-9CED-BE0F404AD8EF}"/>
               </a:ext>
             </a:extLst>
           </p:cNvPr>
@@ -6187,7 +6207,7 @@
                 <a:ea typeface="Arial"/>
                 <a:cs typeface="Arial"/>
               </a:rPr>
-              <a:t>Add expense export and backups.</a:t>
+              <a:t>Add expense export and backup policy.</a:t>
             </a:r>
           </a:p>
           <a:p xmlns:a="http://schemas.openxmlformats.org/drawingml/2006/main">
@@ -6215,7 +6235,7 @@
                 <a:ea typeface="Arial"/>
                 <a:cs typeface="Arial"/>
               </a:rPr>
-              <a:t>Review production hosting and monitoring.</a:t>
+              <a:t>Add shared rate controls and monitoring.</a:t>
             </a:r>
           </a:p>
         </p:txBody>
@@ -6225,7 +6245,7 @@
           <p:cNvPr id="8" name="acknowledgement">
             <a:extLst xmlns:a="http://schemas.openxmlformats.org/drawingml/2006/main">
               <a:ext uri="{FF2B5EF4-FFF2-40B4-BE49-F238E27FC236}">
-                <a16:creationId xmlns:a16="http://schemas.microsoft.com/office/drawing/2014/main" id="{FECF5781-5466-47F8-9DF7-34D9D7FE3629}"/>
+                <a16:creationId xmlns:a16="http://schemas.microsoft.com/office/drawing/2014/main" id="{34A1B2F5-78C5-4C9A-8F88-14F8E8A9DE66}"/>
               </a:ext>
             </a:extLst>
           </p:cNvPr>
@@ -6381,7 +6401,7 @@
     </p:spTree>
     <p:extLst>
       <p:ext uri="{BB962C8B-B14F-4D97-AF65-F5344CB8AC3E}">
-        <p14:creationId xmlns:p14="http://schemas.microsoft.com/office/powerpoint/2010/main" val="403296974"/>
+        <p14:creationId xmlns:p14="http://schemas.microsoft.com/office/powerpoint/2010/main" val="2020695401"/>
       </p:ext>
     </p:extLst>
   </p:cSld>
@@ -6412,7 +6432,7 @@
           <p:cNvPr id="7" name="accent">
             <a:extLst xmlns:a="http://schemas.openxmlformats.org/drawingml/2006/main">
               <a:ext uri="{FF2B5EF4-FFF2-40B4-BE49-F238E27FC236}">
-                <a16:creationId xmlns:a16="http://schemas.microsoft.com/office/drawing/2014/main" id="{58DA9758-0F14-42BC-9B6B-91E0568CFDA9}"/>
+                <a16:creationId xmlns:a16="http://schemas.microsoft.com/office/drawing/2014/main" id="{7D6A269D-07B7-4276-8479-04581348CB37}"/>
               </a:ext>
             </a:extLst>
           </p:cNvPr>
@@ -6442,7 +6462,7 @@
           <p:cNvPr id="2" name="title">
             <a:extLst xmlns:a="http://schemas.openxmlformats.org/drawingml/2006/main">
               <a:ext uri="{FF2B5EF4-FFF2-40B4-BE49-F238E27FC236}">
-                <a16:creationId xmlns:a16="http://schemas.microsoft.com/office/drawing/2014/main" id="{F1BCCE27-572C-49F9-93FF-A84E0B718F2A}"/>
+                <a16:creationId xmlns:a16="http://schemas.microsoft.com/office/drawing/2014/main" id="{94200062-55C4-4746-9370-8E6F8AA47600}"/>
               </a:ext>
             </a:extLst>
           </p:cNvPr>
@@ -6600,7 +6620,7 @@
           <p:cNvPr id="3" name="number">
             <a:extLst xmlns:a="http://schemas.openxmlformats.org/drawingml/2006/main">
               <a:ext uri="{FF2B5EF4-FFF2-40B4-BE49-F238E27FC236}">
-                <a16:creationId xmlns:a16="http://schemas.microsoft.com/office/drawing/2014/main" id="{14C1C797-0848-4E79-BBC2-DE2E7117CD77}"/>
+                <a16:creationId xmlns:a16="http://schemas.microsoft.com/office/drawing/2014/main" id="{B41DDCAD-DEA3-46FD-8DAD-28CBCB858C3C}"/>
               </a:ext>
             </a:extLst>
           </p:cNvPr>
@@ -6758,7 +6778,7 @@
           <p:cNvPr id="4" name="scope-intro">
             <a:extLst xmlns:a="http://schemas.openxmlformats.org/drawingml/2006/main">
               <a:ext uri="{FF2B5EF4-FFF2-40B4-BE49-F238E27FC236}">
-                <a16:creationId xmlns:a16="http://schemas.microsoft.com/office/drawing/2014/main" id="{483FAC42-854A-4641-BFA0-F015B718FF7A}"/>
+                <a16:creationId xmlns:a16="http://schemas.microsoft.com/office/drawing/2014/main" id="{87580F6E-196A-47AC-AD89-FBD11EE30B77}"/>
               </a:ext>
             </a:extLst>
           </p:cNvPr>
@@ -6916,7 +6936,7 @@
           <p:cNvPr id="5" name="">
             <a:extLst xmlns:a="http://schemas.openxmlformats.org/drawingml/2006/main">
               <a:ext uri="{FF2B5EF4-FFF2-40B4-BE49-F238E27FC236}">
-                <a16:creationId xmlns:a16="http://schemas.microsoft.com/office/drawing/2014/main" id="{B39D471E-0975-4F60-A654-A5BCF03CB34D}"/>
+                <a16:creationId xmlns:a16="http://schemas.microsoft.com/office/drawing/2014/main" id="{DACDBE7F-4679-4148-B913-63B95B20789F}"/>
               </a:ext>
             </a:extLst>
           </p:cNvPr>
@@ -7695,7 +7715,7 @@
           <p:cNvPr id="6" name="scope-boundary">
             <a:extLst xmlns:a="http://schemas.openxmlformats.org/drawingml/2006/main">
               <a:ext uri="{FF2B5EF4-FFF2-40B4-BE49-F238E27FC236}">
-                <a16:creationId xmlns:a16="http://schemas.microsoft.com/office/drawing/2014/main" id="{62AB5A25-15F7-4CFE-95E5-440DD07B2F9E}"/>
+                <a16:creationId xmlns:a16="http://schemas.microsoft.com/office/drawing/2014/main" id="{E266DCBE-CD1C-4817-8EFB-6DE85DF71D8C}"/>
               </a:ext>
             </a:extLst>
           </p:cNvPr>
@@ -7843,7 +7863,7 @@
                 <a:ea typeface="Arial"/>
                 <a:cs typeface="Arial"/>
               </a:rPr>
-              <a:t>The four assistant tools share a provider. Expenses use the local database.</a:t>
+              <a:t>The four assistant tools share a provider. Expenses use persistent database storage.</a:t>
             </a:r>
           </a:p>
         </p:txBody>
@@ -7851,7 +7871,7 @@
     </p:spTree>
     <p:extLst>
       <p:ext uri="{BB962C8B-B14F-4D97-AF65-F5344CB8AC3E}">
-        <p14:creationId xmlns:p14="http://schemas.microsoft.com/office/powerpoint/2010/main" val="650059891"/>
+        <p14:creationId xmlns:p14="http://schemas.microsoft.com/office/powerpoint/2010/main" val="1920839017"/>
       </p:ext>
     </p:extLst>
   </p:cSld>
@@ -7882,7 +7902,7 @@
           <p:cNvPr id="13" name="">
             <a:extLst xmlns:a="http://schemas.openxmlformats.org/drawingml/2006/main">
               <a:ext uri="{FF2B5EF4-FFF2-40B4-BE49-F238E27FC236}">
-                <a16:creationId xmlns:a16="http://schemas.microsoft.com/office/drawing/2014/main" id="{7AE8046F-B5F5-4EE4-ABC1-38A4CF9AE81C}"/>
+                <a16:creationId xmlns:a16="http://schemas.microsoft.com/office/drawing/2014/main" id="{B15D071C-C2BD-442E-B9AE-8263FA6C7A6D}"/>
               </a:ext>
             </a:extLst>
           </p:cNvPr>
@@ -7913,7 +7933,7 @@
           <p:cNvPr id="12" name="">
             <a:extLst xmlns:a="http://schemas.openxmlformats.org/drawingml/2006/main">
               <a:ext uri="{FF2B5EF4-FFF2-40B4-BE49-F238E27FC236}">
-                <a16:creationId xmlns:a16="http://schemas.microsoft.com/office/drawing/2014/main" id="{F8DCFD1E-43F0-4D54-B8CD-BF34CCB667DC}"/>
+                <a16:creationId xmlns:a16="http://schemas.microsoft.com/office/drawing/2014/main" id="{DF5C6A72-E7AB-4881-971D-B0E01D034E1B}"/>
               </a:ext>
             </a:extLst>
           </p:cNvPr>
@@ -7944,7 +7964,7 @@
           <p:cNvPr id="9" name="">
             <a:extLst xmlns:a="http://schemas.openxmlformats.org/drawingml/2006/main">
               <a:ext uri="{FF2B5EF4-FFF2-40B4-BE49-F238E27FC236}">
-                <a16:creationId xmlns:a16="http://schemas.microsoft.com/office/drawing/2014/main" id="{58BA2851-1BF5-4EB1-B891-B8BFF1D3A106}"/>
+                <a16:creationId xmlns:a16="http://schemas.microsoft.com/office/drawing/2014/main" id="{F24A3EA9-7BD3-427F-8A8F-758DB247D881}"/>
               </a:ext>
             </a:extLst>
           </p:cNvPr>
@@ -7975,7 +7995,7 @@
           <p:cNvPr id="8" name="">
             <a:extLst xmlns:a="http://schemas.openxmlformats.org/drawingml/2006/main">
               <a:ext uri="{FF2B5EF4-FFF2-40B4-BE49-F238E27FC236}">
-                <a16:creationId xmlns:a16="http://schemas.microsoft.com/office/drawing/2014/main" id="{4F07F61B-D7AE-4E70-8C29-F0BBEACF0FBF}"/>
+                <a16:creationId xmlns:a16="http://schemas.microsoft.com/office/drawing/2014/main" id="{34C7CEC7-5B19-45CA-8687-CCA1667CEC7E}"/>
               </a:ext>
             </a:extLst>
           </p:cNvPr>
@@ -8006,7 +8026,7 @@
           <p:cNvPr id="15" name="accent">
             <a:extLst xmlns:a="http://schemas.openxmlformats.org/drawingml/2006/main">
               <a:ext uri="{FF2B5EF4-FFF2-40B4-BE49-F238E27FC236}">
-                <a16:creationId xmlns:a16="http://schemas.microsoft.com/office/drawing/2014/main" id="{B034FEBF-977A-43B1-AFD6-383789412490}"/>
+                <a16:creationId xmlns:a16="http://schemas.microsoft.com/office/drawing/2014/main" id="{197F125E-3197-448A-8AB8-A0A14C5D8ECD}"/>
               </a:ext>
             </a:extLst>
           </p:cNvPr>
@@ -8036,7 +8056,7 @@
           <p:cNvPr id="2" name="title">
             <a:extLst xmlns:a="http://schemas.openxmlformats.org/drawingml/2006/main">
               <a:ext uri="{FF2B5EF4-FFF2-40B4-BE49-F238E27FC236}">
-                <a16:creationId xmlns:a16="http://schemas.microsoft.com/office/drawing/2014/main" id="{DB1C8704-DB54-436A-8E52-2FFBD672FE6A}"/>
+                <a16:creationId xmlns:a16="http://schemas.microsoft.com/office/drawing/2014/main" id="{A7BB55FD-A60A-4A93-BEC9-8135CC98EA40}"/>
               </a:ext>
             </a:extLst>
           </p:cNvPr>
@@ -8194,7 +8214,7 @@
           <p:cNvPr id="3" name="number">
             <a:extLst xmlns:a="http://schemas.openxmlformats.org/drawingml/2006/main">
               <a:ext uri="{FF2B5EF4-FFF2-40B4-BE49-F238E27FC236}">
-                <a16:creationId xmlns:a16="http://schemas.microsoft.com/office/drawing/2014/main" id="{C6535F04-0C5B-4AA3-BC81-315B079AC8D6}"/>
+                <a16:creationId xmlns:a16="http://schemas.microsoft.com/office/drawing/2014/main" id="{9884F4E8-6257-4199-BA46-3B29D8259721}"/>
               </a:ext>
             </a:extLst>
           </p:cNvPr>
@@ -8352,7 +8372,7 @@
           <p:cNvPr id="4" name="architecture-intro">
             <a:extLst xmlns:a="http://schemas.openxmlformats.org/drawingml/2006/main">
               <a:ext uri="{FF2B5EF4-FFF2-40B4-BE49-F238E27FC236}">
-                <a16:creationId xmlns:a16="http://schemas.microsoft.com/office/drawing/2014/main" id="{4BF8AB97-C8E5-4876-A406-56805D90B6F0}"/>
+                <a16:creationId xmlns:a16="http://schemas.microsoft.com/office/drawing/2014/main" id="{7CD3C337-B99D-48E7-93CA-54D11FB5FBB2}"/>
               </a:ext>
             </a:extLst>
           </p:cNvPr>
@@ -8510,7 +8530,7 @@
           <p:cNvPr id="5" name="Browser HTML / CSS / JavaScript">
             <a:extLst xmlns:a="http://schemas.openxmlformats.org/drawingml/2006/main">
               <a:ext uri="{FF2B5EF4-FFF2-40B4-BE49-F238E27FC236}">
-                <a16:creationId xmlns:a16="http://schemas.microsoft.com/office/drawing/2014/main" id="{5284EF10-212B-4865-91A7-EFD23C7F455D}"/>
+                <a16:creationId xmlns:a16="http://schemas.microsoft.com/office/drawing/2014/main" id="{58EE6990-6593-49EE-A6BB-9F484902AAE7}"/>
               </a:ext>
             </a:extLst>
           </p:cNvPr>
@@ -8690,10 +8710,10 @@
       </p:sp>
       <p:sp>
         <p:nvSpPr>
-          <p:cNvPr id="6" name="Django Routes and views">
+          <p:cNvPr id="6" name="Django Vercel server">
             <a:extLst xmlns:a="http://schemas.openxmlformats.org/drawingml/2006/main">
               <a:ext uri="{FF2B5EF4-FFF2-40B4-BE49-F238E27FC236}">
-                <a16:creationId xmlns:a16="http://schemas.microsoft.com/office/drawing/2014/main" id="{731F4CD6-9585-4121-B1B6-9A3D5F3969CC}"/>
+                <a16:creationId xmlns:a16="http://schemas.microsoft.com/office/drawing/2014/main" id="{4BDEA7AD-CA6C-4221-9FD4-EC1296399E67}"/>
               </a:ext>
             </a:extLst>
           </p:cNvPr>
@@ -8866,7 +8886,7 @@
                 <a:ea typeface="Arial"/>
                 <a:cs typeface="Arial"/>
               </a:rPr>
-              <a:t>Routes and views</a:t>
+              <a:t>Vercel server</a:t>
             </a:r>
           </a:p>
         </p:txBody>
@@ -8876,7 +8896,7 @@
           <p:cNvPr id="7" name="Assistant provider Sample or live Gemini">
             <a:extLst xmlns:a="http://schemas.openxmlformats.org/drawingml/2006/main">
               <a:ext uri="{FF2B5EF4-FFF2-40B4-BE49-F238E27FC236}">
-                <a16:creationId xmlns:a16="http://schemas.microsoft.com/office/drawing/2014/main" id="{5C8A1B13-5F81-42FF-85AE-3F0B2A808E8F}"/>
+                <a16:creationId xmlns:a16="http://schemas.microsoft.com/office/drawing/2014/main" id="{CD098DF3-E25A-43C9-B32F-3AC2DD37C5F3}"/>
               </a:ext>
             </a:extLst>
           </p:cNvPr>
@@ -9059,7 +9079,7 @@
           <p:cNvPr id="10" name="Django session Browser ownership">
             <a:extLst xmlns:a="http://schemas.openxmlformats.org/drawingml/2006/main">
               <a:ext uri="{FF2B5EF4-FFF2-40B4-BE49-F238E27FC236}">
-                <a16:creationId xmlns:a16="http://schemas.microsoft.com/office/drawing/2014/main" id="{2C561E49-3F78-4FAF-AB33-82930CDFD80D}"/>
+                <a16:creationId xmlns:a16="http://schemas.microsoft.com/office/drawing/2014/main" id="{CE309EFB-8BF1-4A72-958E-E803B7E14893}"/>
               </a:ext>
             </a:extLst>
           </p:cNvPr>
@@ -9239,10 +9259,10 @@
       </p:sp>
       <p:sp>
         <p:nvSpPr>
-          <p:cNvPr id="11" name="SQLite Expenses and budget">
+          <p:cNvPr id="11" name="Neon / SQLite Hosted / local">
             <a:extLst xmlns:a="http://schemas.openxmlformats.org/drawingml/2006/main">
               <a:ext uri="{FF2B5EF4-FFF2-40B4-BE49-F238E27FC236}">
-                <a16:creationId xmlns:a16="http://schemas.microsoft.com/office/drawing/2014/main" id="{C60BACB3-D1AC-47A0-8D8E-8DC314A83796}"/>
+                <a16:creationId xmlns:a16="http://schemas.microsoft.com/office/drawing/2014/main" id="{577E7D45-C204-46DF-849C-2049236C4E19}"/>
               </a:ext>
             </a:extLst>
           </p:cNvPr>
@@ -9392,7 +9412,7 @@
                 <a:ea typeface="Arial"/>
                 <a:cs typeface="Arial"/>
               </a:rPr>
-              <a:t>SQLite</a:t>
+              <a:t>Neon / SQLite</a:t>
             </a:r>
           </a:p>
           <a:p xmlns:a="http://schemas.openxmlformats.org/drawingml/2006/main">
@@ -9415,7 +9435,7 @@
                 <a:ea typeface="Arial"/>
                 <a:cs typeface="Arial"/>
               </a:rPr>
-              <a:t>Expenses and budget</a:t>
+              <a:t>Hosted / local</a:t>
             </a:r>
           </a:p>
         </p:txBody>
@@ -9425,7 +9445,7 @@
           <p:cNvPr id="14" name="architecture-detail">
             <a:extLst xmlns:a="http://schemas.openxmlformats.org/drawingml/2006/main">
               <a:ext uri="{FF2B5EF4-FFF2-40B4-BE49-F238E27FC236}">
-                <a16:creationId xmlns:a16="http://schemas.microsoft.com/office/drawing/2014/main" id="{546F476C-97A9-4C1F-A6A4-86B1DAB26491}"/>
+                <a16:creationId xmlns:a16="http://schemas.microsoft.com/office/drawing/2014/main" id="{941D1586-00D2-4775-B905-0FD765BD1CF9}"/>
               </a:ext>
             </a:extLst>
           </p:cNvPr>
@@ -9573,7 +9593,7 @@
                 <a:ea typeface="Arial"/>
                 <a:cs typeface="Arial"/>
               </a:rPr>
-              <a:t>CSRF protection and input validation apply before processing. AI credentials stay on the server.</a:t>
+              <a:t>Hosted in Singapore with Neon PostgreSQL and TLS. Local development retains SQLite.</a:t>
             </a:r>
           </a:p>
         </p:txBody>
@@ -9581,7 +9601,7 @@
     </p:spTree>
     <p:extLst>
       <p:ext uri="{BB962C8B-B14F-4D97-AF65-F5344CB8AC3E}">
-        <p14:creationId xmlns:p14="http://schemas.microsoft.com/office/powerpoint/2010/main" val="1553910319"/>
+        <p14:creationId xmlns:p14="http://schemas.microsoft.com/office/powerpoint/2010/main" val="30840493"/>
       </p:ext>
     </p:extLst>
   </p:cSld>
@@ -9612,7 +9632,7 @@
           <p:cNvPr id="10" name="accent">
             <a:extLst xmlns:a="http://schemas.openxmlformats.org/drawingml/2006/main">
               <a:ext uri="{FF2B5EF4-FFF2-40B4-BE49-F238E27FC236}">
-                <a16:creationId xmlns:a16="http://schemas.microsoft.com/office/drawing/2014/main" id="{37780253-8F48-4D83-906A-621CA68F966E}"/>
+                <a16:creationId xmlns:a16="http://schemas.microsoft.com/office/drawing/2014/main" id="{83116783-D5F1-4F7E-BA98-92CD5D9DB84D}"/>
               </a:ext>
             </a:extLst>
           </p:cNvPr>
@@ -9642,7 +9662,7 @@
           <p:cNvPr id="2" name="title">
             <a:extLst xmlns:a="http://schemas.openxmlformats.org/drawingml/2006/main">
               <a:ext uri="{FF2B5EF4-FFF2-40B4-BE49-F238E27FC236}">
-                <a16:creationId xmlns:a16="http://schemas.microsoft.com/office/drawing/2014/main" id="{26060B4B-34F7-49F6-A2D0-CB70FA3A7A3F}"/>
+                <a16:creationId xmlns:a16="http://schemas.microsoft.com/office/drawing/2014/main" id="{03F6CB3F-FBE9-437E-B2DC-847D6F0A608F}"/>
               </a:ext>
             </a:extLst>
           </p:cNvPr>
@@ -9800,7 +9820,7 @@
           <p:cNvPr id="3" name="number">
             <a:extLst xmlns:a="http://schemas.openxmlformats.org/drawingml/2006/main">
               <a:ext uri="{FF2B5EF4-FFF2-40B4-BE49-F238E27FC236}">
-                <a16:creationId xmlns:a16="http://schemas.microsoft.com/office/drawing/2014/main" id="{879F5D37-5561-45C7-8342-05054A4F3D92}"/>
+                <a16:creationId xmlns:a16="http://schemas.microsoft.com/office/drawing/2014/main" id="{1AFFD1EC-4FBA-49CA-B5F6-4E34FC6E1E4E}"/>
               </a:ext>
             </a:extLst>
           </p:cNvPr>
@@ -9958,7 +9978,7 @@
           <p:cNvPr id="4" name="sample-heading">
             <a:extLst xmlns:a="http://schemas.openxmlformats.org/drawingml/2006/main">
               <a:ext uri="{FF2B5EF4-FFF2-40B4-BE49-F238E27FC236}">
-                <a16:creationId xmlns:a16="http://schemas.microsoft.com/office/drawing/2014/main" id="{F913CBCF-5106-4359-8E9B-CCC849E2C7BC}"/>
+                <a16:creationId xmlns:a16="http://schemas.microsoft.com/office/drawing/2014/main" id="{508D5A57-9086-4106-9E46-01F7B4A1EEAB}"/>
               </a:ext>
             </a:extLst>
           </p:cNvPr>
@@ -10116,7 +10136,7 @@
           <p:cNvPr id="5" name="sample-body">
             <a:extLst xmlns:a="http://schemas.openxmlformats.org/drawingml/2006/main">
               <a:ext uri="{FF2B5EF4-FFF2-40B4-BE49-F238E27FC236}">
-                <a16:creationId xmlns:a16="http://schemas.microsoft.com/office/drawing/2014/main" id="{43DD9847-D191-4A1D-A974-38D01B5051FA}"/>
+                <a16:creationId xmlns:a16="http://schemas.microsoft.com/office/drawing/2014/main" id="{31BE3D73-A806-4459-850A-E39D8B0A6267}"/>
               </a:ext>
             </a:extLst>
           </p:cNvPr>
@@ -10358,7 +10378,7 @@
           <p:cNvPr id="6" name="live-heading">
             <a:extLst xmlns:a="http://schemas.openxmlformats.org/drawingml/2006/main">
               <a:ext uri="{FF2B5EF4-FFF2-40B4-BE49-F238E27FC236}">
-                <a16:creationId xmlns:a16="http://schemas.microsoft.com/office/drawing/2014/main" id="{2C68C0AF-D4E0-4D1C-ABEF-D4DBD985D5D5}"/>
+                <a16:creationId xmlns:a16="http://schemas.microsoft.com/office/drawing/2014/main" id="{C40BA3DF-52FC-4416-85AF-17722A43930E}"/>
               </a:ext>
             </a:extLst>
           </p:cNvPr>
@@ -10516,7 +10536,7 @@
           <p:cNvPr id="7" name="live-body">
             <a:extLst xmlns:a="http://schemas.openxmlformats.org/drawingml/2006/main">
               <a:ext uri="{FF2B5EF4-FFF2-40B4-BE49-F238E27FC236}">
-                <a16:creationId xmlns:a16="http://schemas.microsoft.com/office/drawing/2014/main" id="{5E01545B-D7A2-44C2-B041-A84D1487D6F8}"/>
+                <a16:creationId xmlns:a16="http://schemas.microsoft.com/office/drawing/2014/main" id="{D9E886AF-A0DF-492C-B65C-BB7513BE78B0}"/>
               </a:ext>
             </a:extLst>
           </p:cNvPr>
@@ -10758,7 +10778,7 @@
           <p:cNvPr id="8" name="mode-rule">
             <a:extLst xmlns:a="http://schemas.openxmlformats.org/drawingml/2006/main">
               <a:ext uri="{FF2B5EF4-FFF2-40B4-BE49-F238E27FC236}">
-                <a16:creationId xmlns:a16="http://schemas.microsoft.com/office/drawing/2014/main" id="{BD1B3D32-FB4E-44EC-8207-B01603AD8EE5}"/>
+                <a16:creationId xmlns:a16="http://schemas.microsoft.com/office/drawing/2014/main" id="{9D47CCFD-5CA6-40F2-BD11-8562A6E462A2}"/>
               </a:ext>
             </a:extLst>
           </p:cNvPr>
@@ -10788,7 +10808,7 @@
           <p:cNvPr id="9" name="mode-risk">
             <a:extLst xmlns:a="http://schemas.openxmlformats.org/drawingml/2006/main">
               <a:ext uri="{FF2B5EF4-FFF2-40B4-BE49-F238E27FC236}">
-                <a16:creationId xmlns:a16="http://schemas.microsoft.com/office/drawing/2014/main" id="{31027F58-C6F2-4881-A9A4-86D8C3B1A014}"/>
+                <a16:creationId xmlns:a16="http://schemas.microsoft.com/office/drawing/2014/main" id="{4AA81AAA-97E1-45D3-8D0B-39B53F089077}"/>
               </a:ext>
             </a:extLst>
           </p:cNvPr>
@@ -10944,7 +10964,7 @@
     </p:spTree>
     <p:extLst>
       <p:ext uri="{BB962C8B-B14F-4D97-AF65-F5344CB8AC3E}">
-        <p14:creationId xmlns:p14="http://schemas.microsoft.com/office/powerpoint/2010/main" val="1319737960"/>
+        <p14:creationId xmlns:p14="http://schemas.microsoft.com/office/powerpoint/2010/main" val="2088964637"/>
       </p:ext>
     </p:extLst>
   </p:cSld>
@@ -10975,7 +10995,7 @@
           <p:cNvPr id="7" name="accent">
             <a:extLst xmlns:a="http://schemas.openxmlformats.org/drawingml/2006/main">
               <a:ext uri="{FF2B5EF4-FFF2-40B4-BE49-F238E27FC236}">
-                <a16:creationId xmlns:a16="http://schemas.microsoft.com/office/drawing/2014/main" id="{EB7ADD59-3CD9-4F7B-B0A2-FFA3E4810D51}"/>
+                <a16:creationId xmlns:a16="http://schemas.microsoft.com/office/drawing/2014/main" id="{B883D866-15B2-42B4-BCB8-543BA5CC5BAF}"/>
               </a:ext>
             </a:extLst>
           </p:cNvPr>
@@ -11005,7 +11025,7 @@
           <p:cNvPr id="2" name="title">
             <a:extLst xmlns:a="http://schemas.openxmlformats.org/drawingml/2006/main">
               <a:ext uri="{FF2B5EF4-FFF2-40B4-BE49-F238E27FC236}">
-                <a16:creationId xmlns:a16="http://schemas.microsoft.com/office/drawing/2014/main" id="{D460AB0C-6CE2-4204-82D9-A201D91E33F8}"/>
+                <a16:creationId xmlns:a16="http://schemas.microsoft.com/office/drawing/2014/main" id="{0DD72134-200D-4AB4-B2B2-76F85F96F76A}"/>
               </a:ext>
             </a:extLst>
           </p:cNvPr>
@@ -11163,7 +11183,7 @@
           <p:cNvPr id="3" name="number">
             <a:extLst xmlns:a="http://schemas.openxmlformats.org/drawingml/2006/main">
               <a:ext uri="{FF2B5EF4-FFF2-40B4-BE49-F238E27FC236}">
-                <a16:creationId xmlns:a16="http://schemas.microsoft.com/office/drawing/2014/main" id="{F6E573DA-F01E-45B6-B0F9-4CD0CF8D5C07}"/>
+                <a16:creationId xmlns:a16="http://schemas.microsoft.com/office/drawing/2014/main" id="{97D0785D-6636-4A20-B9A2-FE1E2E948F29}"/>
               </a:ext>
             </a:extLst>
           </p:cNvPr>
@@ -11321,7 +11341,7 @@
           <p:cNvPr id="4" name="">
             <a:extLst xmlns:a="http://schemas.openxmlformats.org/drawingml/2006/main">
               <a:ext uri="{FF2B5EF4-FFF2-40B4-BE49-F238E27FC236}">
-                <a16:creationId xmlns:a16="http://schemas.microsoft.com/office/drawing/2014/main" id="{BFA7DCA6-E258-445E-99FF-4FDAE592385E}"/>
+                <a16:creationId xmlns:a16="http://schemas.microsoft.com/office/drawing/2014/main" id="{E0E4902D-876D-475D-92CD-F57E056B8C0F}"/>
               </a:ext>
             </a:extLst>
           </p:cNvPr>
@@ -11331,7 +11351,7 @@
           <p:nvPr/>
         </p:nvPicPr>
         <p:blipFill>
-          <a:blip xmlns:r="http://schemas.openxmlformats.org/officeDocument/2006/relationships" xmlns:a="http://schemas.openxmlformats.org/drawingml/2006/main" r:embed="R47ee156cf5ac4309"/>
+          <a:blip xmlns:r="http://schemas.openxmlformats.org/officeDocument/2006/relationships" xmlns:a="http://schemas.openxmlformats.org/drawingml/2006/main" r:embed="Rcd70b92b03fb49d5"/>
           <a:stretch xmlns:a="http://schemas.openxmlformats.org/drawingml/2006/main"/>
         </p:blipFill>
         <p:spPr>
@@ -11349,7 +11369,7 @@
           <p:cNvPr id="5" name="dashboard-caption-title">
             <a:extLst xmlns:a="http://schemas.openxmlformats.org/drawingml/2006/main">
               <a:ext uri="{FF2B5EF4-FFF2-40B4-BE49-F238E27FC236}">
-                <a16:creationId xmlns:a16="http://schemas.microsoft.com/office/drawing/2014/main" id="{71BCF694-7731-4B40-8C8E-B0413848A79C}"/>
+                <a16:creationId xmlns:a16="http://schemas.microsoft.com/office/drawing/2014/main" id="{46E2BADE-A16B-48A7-A665-7EEFF1E8C73E}"/>
               </a:ext>
             </a:extLst>
           </p:cNvPr>
@@ -11507,7 +11527,7 @@
           <p:cNvPr id="6" name="dashboard-caption">
             <a:extLst xmlns:a="http://schemas.openxmlformats.org/drawingml/2006/main">
               <a:ext uri="{FF2B5EF4-FFF2-40B4-BE49-F238E27FC236}">
-                <a16:creationId xmlns:a16="http://schemas.microsoft.com/office/drawing/2014/main" id="{B3673368-9D98-4A0A-932F-EB40514EF5C6}"/>
+                <a16:creationId xmlns:a16="http://schemas.microsoft.com/office/drawing/2014/main" id="{8C262460-1678-4EC7-93B1-F07F06E42741}"/>
               </a:ext>
             </a:extLst>
           </p:cNvPr>
@@ -11691,7 +11711,7 @@
     </p:spTree>
     <p:extLst>
       <p:ext uri="{BB962C8B-B14F-4D97-AF65-F5344CB8AC3E}">
-        <p14:creationId xmlns:p14="http://schemas.microsoft.com/office/powerpoint/2010/main" val="940342100"/>
+        <p14:creationId xmlns:p14="http://schemas.microsoft.com/office/powerpoint/2010/main" val="1317667431"/>
       </p:ext>
     </p:extLst>
   </p:cSld>
@@ -11722,7 +11742,7 @@
           <p:cNvPr id="10" name="accent">
             <a:extLst xmlns:a="http://schemas.openxmlformats.org/drawingml/2006/main">
               <a:ext uri="{FF2B5EF4-FFF2-40B4-BE49-F238E27FC236}">
-                <a16:creationId xmlns:a16="http://schemas.microsoft.com/office/drawing/2014/main" id="{2BDFA05D-782D-4643-AF81-BE34D9DA7076}"/>
+                <a16:creationId xmlns:a16="http://schemas.microsoft.com/office/drawing/2014/main" id="{3E9CD5A3-F8E4-440B-A535-B896D26E3845}"/>
               </a:ext>
             </a:extLst>
           </p:cNvPr>
@@ -11752,7 +11772,7 @@
           <p:cNvPr id="2" name="title">
             <a:extLst xmlns:a="http://schemas.openxmlformats.org/drawingml/2006/main">
               <a:ext uri="{FF2B5EF4-FFF2-40B4-BE49-F238E27FC236}">
-                <a16:creationId xmlns:a16="http://schemas.microsoft.com/office/drawing/2014/main" id="{11A52ACD-4856-493A-AB2E-14C3ABA07D19}"/>
+                <a16:creationId xmlns:a16="http://schemas.microsoft.com/office/drawing/2014/main" id="{48CE9396-C09E-47B0-9B5F-CEDB1876EA67}"/>
               </a:ext>
             </a:extLst>
           </p:cNvPr>
@@ -11910,7 +11930,7 @@
           <p:cNvPr id="3" name="number">
             <a:extLst xmlns:a="http://schemas.openxmlformats.org/drawingml/2006/main">
               <a:ext uri="{FF2B5EF4-FFF2-40B4-BE49-F238E27FC236}">
-                <a16:creationId xmlns:a16="http://schemas.microsoft.com/office/drawing/2014/main" id="{3D1AE4F1-2BF3-457F-AD9F-A89BEA07583E}"/>
+                <a16:creationId xmlns:a16="http://schemas.microsoft.com/office/drawing/2014/main" id="{6DBB5F02-244A-4876-903D-711EEA4F240A}"/>
               </a:ext>
             </a:extLst>
           </p:cNvPr>
@@ -12068,7 +12088,7 @@
           <p:cNvPr id="4" name="recipe-label">
             <a:extLst xmlns:a="http://schemas.openxmlformats.org/drawingml/2006/main">
               <a:ext uri="{FF2B5EF4-FFF2-40B4-BE49-F238E27FC236}">
-                <a16:creationId xmlns:a16="http://schemas.microsoft.com/office/drawing/2014/main" id="{5B0FBB47-C562-4E0E-B125-EB10290A81D0}"/>
+                <a16:creationId xmlns:a16="http://schemas.microsoft.com/office/drawing/2014/main" id="{7F14E2D7-C8D5-4071-9746-6986B1D607C4}"/>
               </a:ext>
             </a:extLst>
           </p:cNvPr>
@@ -12226,7 +12246,7 @@
           <p:cNvPr id="5" name="travel-label">
             <a:extLst xmlns:a="http://schemas.openxmlformats.org/drawingml/2006/main">
               <a:ext uri="{FF2B5EF4-FFF2-40B4-BE49-F238E27FC236}">
-                <a16:creationId xmlns:a16="http://schemas.microsoft.com/office/drawing/2014/main" id="{BF88212C-2DFB-4909-996D-AA6D02FEF1A3}"/>
+                <a16:creationId xmlns:a16="http://schemas.microsoft.com/office/drawing/2014/main" id="{3B80D454-FE51-45F8-B1FB-C50ECCF02E8C}"/>
               </a:ext>
             </a:extLst>
           </p:cNvPr>
@@ -12384,7 +12404,7 @@
           <p:cNvPr id="6" name="">
             <a:extLst xmlns:a="http://schemas.openxmlformats.org/drawingml/2006/main">
               <a:ext uri="{FF2B5EF4-FFF2-40B4-BE49-F238E27FC236}">
-                <a16:creationId xmlns:a16="http://schemas.microsoft.com/office/drawing/2014/main" id="{5CAFDC1F-5FC9-4115-BD80-7ACCBE94C1AE}"/>
+                <a16:creationId xmlns:a16="http://schemas.microsoft.com/office/drawing/2014/main" id="{3ED8842C-6078-4582-912C-FEC36276E1E2}"/>
               </a:ext>
             </a:extLst>
           </p:cNvPr>
@@ -12394,7 +12414,7 @@
           <p:nvPr/>
         </p:nvPicPr>
         <p:blipFill>
-          <a:blip xmlns:r="http://schemas.openxmlformats.org/officeDocument/2006/relationships" xmlns:a="http://schemas.openxmlformats.org/drawingml/2006/main" r:embed="R5b412b81e64a4ad1"/>
+          <a:blip xmlns:r="http://schemas.openxmlformats.org/officeDocument/2006/relationships" xmlns:a="http://schemas.openxmlformats.org/drawingml/2006/main" r:embed="R2b02e7a8ea8f442d"/>
           <a:stretch xmlns:a="http://schemas.openxmlformats.org/drawingml/2006/main"/>
         </p:blipFill>
         <p:spPr>
@@ -12412,7 +12432,7 @@
           <p:cNvPr id="7" name="">
             <a:extLst xmlns:a="http://schemas.openxmlformats.org/drawingml/2006/main">
               <a:ext uri="{FF2B5EF4-FFF2-40B4-BE49-F238E27FC236}">
-                <a16:creationId xmlns:a16="http://schemas.microsoft.com/office/drawing/2014/main" id="{54884336-2300-4D06-87B9-9E39AA97B5DB}"/>
+                <a16:creationId xmlns:a16="http://schemas.microsoft.com/office/drawing/2014/main" id="{54785EFB-7B08-4D80-93C4-6634666E5D2A}"/>
               </a:ext>
             </a:extLst>
           </p:cNvPr>
@@ -12422,7 +12442,7 @@
           <p:nvPr/>
         </p:nvPicPr>
         <p:blipFill>
-          <a:blip xmlns:r="http://schemas.openxmlformats.org/officeDocument/2006/relationships" xmlns:a="http://schemas.openxmlformats.org/drawingml/2006/main" r:embed="R0b0ce783848a4589"/>
+          <a:blip xmlns:r="http://schemas.openxmlformats.org/officeDocument/2006/relationships" xmlns:a="http://schemas.openxmlformats.org/drawingml/2006/main" r:embed="Rba71306188ed4e1e"/>
           <a:stretch xmlns:a="http://schemas.openxmlformats.org/drawingml/2006/main"/>
         </p:blipFill>
         <p:spPr>
@@ -12440,7 +12460,7 @@
           <p:cNvPr id="8" name="recipe-caption">
             <a:extLst xmlns:a="http://schemas.openxmlformats.org/drawingml/2006/main">
               <a:ext uri="{FF2B5EF4-FFF2-40B4-BE49-F238E27FC236}">
-                <a16:creationId xmlns:a16="http://schemas.microsoft.com/office/drawing/2014/main" id="{A447A1C2-1C4C-4BCD-BDED-8C1CE0745113}"/>
+                <a16:creationId xmlns:a16="http://schemas.microsoft.com/office/drawing/2014/main" id="{F6C6F066-0DB4-4B44-9DD9-4DC6878B6E59}"/>
               </a:ext>
             </a:extLst>
           </p:cNvPr>
@@ -12598,7 +12618,7 @@
           <p:cNvPr id="9" name="travel-caption">
             <a:extLst xmlns:a="http://schemas.openxmlformats.org/drawingml/2006/main">
               <a:ext uri="{FF2B5EF4-FFF2-40B4-BE49-F238E27FC236}">
-                <a16:creationId xmlns:a16="http://schemas.microsoft.com/office/drawing/2014/main" id="{C7780FE1-A3BD-4DDA-8C98-4BC14803F743}"/>
+                <a16:creationId xmlns:a16="http://schemas.microsoft.com/office/drawing/2014/main" id="{7A956174-0EEF-4869-B10B-A927C44FFCF6}"/>
               </a:ext>
             </a:extLst>
           </p:cNvPr>
@@ -12754,7 +12774,7 @@
     </p:spTree>
     <p:extLst>
       <p:ext uri="{BB962C8B-B14F-4D97-AF65-F5344CB8AC3E}">
-        <p14:creationId xmlns:p14="http://schemas.microsoft.com/office/powerpoint/2010/main" val="1442013766"/>
+        <p14:creationId xmlns:p14="http://schemas.microsoft.com/office/powerpoint/2010/main" val="1289607933"/>
       </p:ext>
     </p:extLst>
   </p:cSld>
@@ -12785,7 +12805,7 @@
           <p:cNvPr id="9" name="accent">
             <a:extLst xmlns:a="http://schemas.openxmlformats.org/drawingml/2006/main">
               <a:ext uri="{FF2B5EF4-FFF2-40B4-BE49-F238E27FC236}">
-                <a16:creationId xmlns:a16="http://schemas.microsoft.com/office/drawing/2014/main" id="{CB4BBD90-44F3-4B51-8674-BC09329664F0}"/>
+                <a16:creationId xmlns:a16="http://schemas.microsoft.com/office/drawing/2014/main" id="{805DC34A-07E2-414C-91B5-75FB053FBAA0}"/>
               </a:ext>
             </a:extLst>
           </p:cNvPr>
@@ -12815,7 +12835,7 @@
           <p:cNvPr id="2" name="title">
             <a:extLst xmlns:a="http://schemas.openxmlformats.org/drawingml/2006/main">
               <a:ext uri="{FF2B5EF4-FFF2-40B4-BE49-F238E27FC236}">
-                <a16:creationId xmlns:a16="http://schemas.microsoft.com/office/drawing/2014/main" id="{4AAA2AB6-A37F-4BC0-BD28-A4F2DC171841}"/>
+                <a16:creationId xmlns:a16="http://schemas.microsoft.com/office/drawing/2014/main" id="{F328E7B0-00A7-4558-8966-3B5AF717BB1E}"/>
               </a:ext>
             </a:extLst>
           </p:cNvPr>
@@ -12973,7 +12993,7 @@
           <p:cNvPr id="3" name="number">
             <a:extLst xmlns:a="http://schemas.openxmlformats.org/drawingml/2006/main">
               <a:ext uri="{FF2B5EF4-FFF2-40B4-BE49-F238E27FC236}">
-                <a16:creationId xmlns:a16="http://schemas.microsoft.com/office/drawing/2014/main" id="{D8BC2489-6AB6-4A42-980C-D5051FFC4ACE}"/>
+                <a16:creationId xmlns:a16="http://schemas.microsoft.com/office/drawing/2014/main" id="{D0C7BBFE-22BA-4A3B-A9E8-9F06551367DA}"/>
               </a:ext>
             </a:extLst>
           </p:cNvPr>
@@ -13131,7 +13151,7 @@
           <p:cNvPr id="4" name="">
             <a:extLst xmlns:a="http://schemas.openxmlformats.org/drawingml/2006/main">
               <a:ext uri="{FF2B5EF4-FFF2-40B4-BE49-F238E27FC236}">
-                <a16:creationId xmlns:a16="http://schemas.microsoft.com/office/drawing/2014/main" id="{96596264-063B-45B4-B156-4D87B4F5193A}"/>
+                <a16:creationId xmlns:a16="http://schemas.microsoft.com/office/drawing/2014/main" id="{7FF6F612-A350-4864-B5F3-03CC14BDC0F8}"/>
               </a:ext>
             </a:extLst>
           </p:cNvPr>
@@ -13141,7 +13161,7 @@
           <p:nvPr/>
         </p:nvPicPr>
         <p:blipFill>
-          <a:blip xmlns:r="http://schemas.openxmlformats.org/officeDocument/2006/relationships" xmlns:a="http://schemas.openxmlformats.org/drawingml/2006/main" r:embed="Rb11fcc00a3df4105"/>
+          <a:blip xmlns:r="http://schemas.openxmlformats.org/officeDocument/2006/relationships" xmlns:a="http://schemas.openxmlformats.org/drawingml/2006/main" r:embed="R2f117c37a57c4e0a"/>
           <a:stretch xmlns:a="http://schemas.openxmlformats.org/drawingml/2006/main"/>
         </p:blipFill>
         <p:spPr>
@@ -13159,7 +13179,7 @@
           <p:cNvPr id="5" name="expense-title">
             <a:extLst xmlns:a="http://schemas.openxmlformats.org/drawingml/2006/main">
               <a:ext uri="{FF2B5EF4-FFF2-40B4-BE49-F238E27FC236}">
-                <a16:creationId xmlns:a16="http://schemas.microsoft.com/office/drawing/2014/main" id="{D957EA75-973D-4E4C-BDE5-C2A1A559F533}"/>
+                <a16:creationId xmlns:a16="http://schemas.microsoft.com/office/drawing/2014/main" id="{D2C96EB4-05D6-4E4B-9D31-FB6292E1B6CF}"/>
               </a:ext>
             </a:extLst>
           </p:cNvPr>
@@ -13317,7 +13337,7 @@
           <p:cNvPr id="6" name="">
             <a:extLst xmlns:a="http://schemas.openxmlformats.org/drawingml/2006/main">
               <a:ext uri="{FF2B5EF4-FFF2-40B4-BE49-F238E27FC236}">
-                <a16:creationId xmlns:a16="http://schemas.microsoft.com/office/drawing/2014/main" id="{64269B79-FA7C-4F26-B78C-C6B6540916BE}"/>
+                <a16:creationId xmlns:a16="http://schemas.microsoft.com/office/drawing/2014/main" id="{02662C3B-72DB-41AC-9F61-A98E1D2B3265}"/>
               </a:ext>
             </a:extLst>
           </p:cNvPr>
@@ -13693,7 +13713,7 @@
           <p:cNvPr id="7" name="expense-body">
             <a:extLst xmlns:a="http://schemas.openxmlformats.org/drawingml/2006/main">
               <a:ext uri="{FF2B5EF4-FFF2-40B4-BE49-F238E27FC236}">
-                <a16:creationId xmlns:a16="http://schemas.microsoft.com/office/drawing/2014/main" id="{FB713FED-F1B4-4429-A66B-EAFC343F4F3F}"/>
+                <a16:creationId xmlns:a16="http://schemas.microsoft.com/office/drawing/2014/main" id="{62E850ED-5546-47AF-A00F-F41A4BC48B83}"/>
               </a:ext>
             </a:extLst>
           </p:cNvPr>
@@ -13897,7 +13917,7 @@
           <p:cNvPr id="8" name="expense-boundary">
             <a:extLst xmlns:a="http://schemas.openxmlformats.org/drawingml/2006/main">
               <a:ext uri="{FF2B5EF4-FFF2-40B4-BE49-F238E27FC236}">
-                <a16:creationId xmlns:a16="http://schemas.microsoft.com/office/drawing/2014/main" id="{357899FF-3C70-43B4-ABBD-9DCABFCBD46C}"/>
+                <a16:creationId xmlns:a16="http://schemas.microsoft.com/office/drawing/2014/main" id="{35AB26FE-07F5-4DD9-85ED-F4B9A9EE5AE3}"/>
               </a:ext>
             </a:extLst>
           </p:cNvPr>
@@ -14053,7 +14073,7 @@
     </p:spTree>
     <p:extLst>
       <p:ext uri="{BB962C8B-B14F-4D97-AF65-F5344CB8AC3E}">
-        <p14:creationId xmlns:p14="http://schemas.microsoft.com/office/powerpoint/2010/main" val="580306846"/>
+        <p14:creationId xmlns:p14="http://schemas.microsoft.com/office/powerpoint/2010/main" val="1546879420"/>
       </p:ext>
     </p:extLst>
   </p:cSld>
@@ -14084,7 +14104,7 @@
           <p:cNvPr id="7" name="accent">
             <a:extLst xmlns:a="http://schemas.openxmlformats.org/drawingml/2006/main">
               <a:ext uri="{FF2B5EF4-FFF2-40B4-BE49-F238E27FC236}">
-                <a16:creationId xmlns:a16="http://schemas.microsoft.com/office/drawing/2014/main" id="{E1CC27EA-77E7-4E5B-A888-21450C52E48E}"/>
+                <a16:creationId xmlns:a16="http://schemas.microsoft.com/office/drawing/2014/main" id="{1F3037A9-278D-49FC-94FB-E22D2973217F}"/>
               </a:ext>
             </a:extLst>
           </p:cNvPr>
@@ -14114,7 +14134,7 @@
           <p:cNvPr id="2" name="title">
             <a:extLst xmlns:a="http://schemas.openxmlformats.org/drawingml/2006/main">
               <a:ext uri="{FF2B5EF4-FFF2-40B4-BE49-F238E27FC236}">
-                <a16:creationId xmlns:a16="http://schemas.microsoft.com/office/drawing/2014/main" id="{37B2C5FA-B5C7-4869-B80B-F3C18A3AA88A}"/>
+                <a16:creationId xmlns:a16="http://schemas.microsoft.com/office/drawing/2014/main" id="{B4F92299-EE22-418C-8626-AF5F5026CA09}"/>
               </a:ext>
             </a:extLst>
           </p:cNvPr>
@@ -14262,7 +14282,7 @@
                 <a:ea typeface="Arial"/>
                 <a:cs typeface="Arial"/>
               </a:rPr>
-              <a:t>Verification covers the working local flow</a:t>
+              <a:t>Verification covers the deployed app</a:t>
             </a:r>
           </a:p>
         </p:txBody>
@@ -14272,7 +14292,7 @@
           <p:cNvPr id="3" name="number">
             <a:extLst xmlns:a="http://schemas.openxmlformats.org/drawingml/2006/main">
               <a:ext uri="{FF2B5EF4-FFF2-40B4-BE49-F238E27FC236}">
-                <a16:creationId xmlns:a16="http://schemas.microsoft.com/office/drawing/2014/main" id="{FAB6B75C-81E0-4CA3-A1E5-9F579EDC4A37}"/>
+                <a16:creationId xmlns:a16="http://schemas.microsoft.com/office/drawing/2014/main" id="{C021F63E-0459-48A7-9A77-85D2F9803EAE}"/>
               </a:ext>
             </a:extLst>
           </p:cNvPr>
@@ -14430,7 +14450,7 @@
           <p:cNvPr id="4" name="verification-headline">
             <a:extLst xmlns:a="http://schemas.openxmlformats.org/drawingml/2006/main">
               <a:ext uri="{FF2B5EF4-FFF2-40B4-BE49-F238E27FC236}">
-                <a16:creationId xmlns:a16="http://schemas.microsoft.com/office/drawing/2014/main" id="{604FE665-2406-4F3F-8F79-FF133D291512}"/>
+                <a16:creationId xmlns:a16="http://schemas.microsoft.com/office/drawing/2014/main" id="{2F9F0B85-12A8-4140-A916-FD2B0028E79E}"/>
               </a:ext>
             </a:extLst>
           </p:cNvPr>
@@ -14578,7 +14598,7 @@
                 <a:ea typeface="Arial"/>
                 <a:cs typeface="Arial"/>
               </a:rPr>
-              <a:t>23 automated tests passed</a:t>
+              <a:t>28 tests passed locally and in GitHub Actions</a:t>
             </a:r>
           </a:p>
         </p:txBody>
@@ -14588,7 +14608,7 @@
           <p:cNvPr id="5" name="">
             <a:extLst xmlns:a="http://schemas.openxmlformats.org/drawingml/2006/main">
               <a:ext uri="{FF2B5EF4-FFF2-40B4-BE49-F238E27FC236}">
-                <a16:creationId xmlns:a16="http://schemas.microsoft.com/office/drawing/2014/main" id="{D78233CA-28C5-45B6-955F-1D398EADE48C}"/>
+                <a16:creationId xmlns:a16="http://schemas.microsoft.com/office/drawing/2014/main" id="{2CF298A2-373B-4B02-9C07-CA48E07D4BD5}"/>
               </a:ext>
             </a:extLst>
           </p:cNvPr>
@@ -14720,7 +14740,7 @@
                           <a:ea typeface="Arial"/>
                           <a:cs typeface="Arial"/>
                         </a:rPr>
-                        <a:t>Backend tests</a:t>
+                        <a:t>Backend and CI</a:t>
                       </a:r>
                     </a:p>
                   </a:txBody>
@@ -14764,7 +14784,7 @@
                           <a:ea typeface="Arial"/>
                           <a:cs typeface="Arial"/>
                         </a:rPr>
-                        <a:t>23 passing automated tests</a:t>
+                        <a:t>28 tests plus Ruff lint and format checks passed</a:t>
                       </a:r>
                     </a:p>
                   </a:txBody>
@@ -14888,7 +14908,7 @@
                           <a:ea typeface="Arial"/>
                           <a:cs typeface="Arial"/>
                         </a:rPr>
-                        <a:t>Code quality</a:t>
+                        <a:t>Hosted storage</a:t>
                       </a:r>
                     </a:p>
                   </a:txBody>
@@ -14932,7 +14952,7 @@
                           <a:ea typeface="Arial"/>
                           <a:cs typeface="Arial"/>
                         </a:rPr>
-                        <a:t>Ruff lint and format checks passed</a:t>
+                        <a:t>Neon PostgreSQL with TLS; migrations completed</a:t>
                       </a:r>
                     </a:p>
                   </a:txBody>
@@ -14972,7 +14992,7 @@
                           <a:ea typeface="Arial"/>
                           <a:cs typeface="Arial"/>
                         </a:rPr>
-                        <a:t>Browser flows</a:t>
+                        <a:t>Public browser QA</a:t>
                       </a:r>
                     </a:p>
                   </a:txBody>
@@ -15132,7 +15152,7 @@
           <p:cNvPr id="6" name="verification-boundary">
             <a:extLst xmlns:a="http://schemas.openxmlformats.org/drawingml/2006/main">
               <a:ext uri="{FF2B5EF4-FFF2-40B4-BE49-F238E27FC236}">
-                <a16:creationId xmlns:a16="http://schemas.microsoft.com/office/drawing/2014/main" id="{6D5C5885-A9FD-47DD-AD71-D4DDDE2F1677}"/>
+                <a16:creationId xmlns:a16="http://schemas.microsoft.com/office/drawing/2014/main" id="{9F3F0B6C-63B9-4FED-ADC9-E16A5E535E70}"/>
               </a:ext>
             </a:extLst>
           </p:cNvPr>
@@ -15288,7 +15308,7 @@
     </p:spTree>
     <p:extLst>
       <p:ext uri="{BB962C8B-B14F-4D97-AF65-F5344CB8AC3E}">
-        <p14:creationId xmlns:p14="http://schemas.microsoft.com/office/powerpoint/2010/main" val="1575325268"/>
+        <p14:creationId xmlns:p14="http://schemas.microsoft.com/office/powerpoint/2010/main" val="1975419081"/>
       </p:ext>
     </p:extLst>
   </p:cSld>
@@ -15319,7 +15339,7 @@
           <p:cNvPr id="9" name="accent">
             <a:extLst xmlns:a="http://schemas.openxmlformats.org/drawingml/2006/main">
               <a:ext uri="{FF2B5EF4-FFF2-40B4-BE49-F238E27FC236}">
-                <a16:creationId xmlns:a16="http://schemas.microsoft.com/office/drawing/2014/main" id="{3A8841EF-1101-4F84-BA26-7CA6AD568E98}"/>
+                <a16:creationId xmlns:a16="http://schemas.microsoft.com/office/drawing/2014/main" id="{37380E96-D03E-4C8A-AEEA-7E7219D9C9C2}"/>
               </a:ext>
             </a:extLst>
           </p:cNvPr>
@@ -15349,7 +15369,7 @@
           <p:cNvPr id="2" name="title">
             <a:extLst xmlns:a="http://schemas.openxmlformats.org/drawingml/2006/main">
               <a:ext uri="{FF2B5EF4-FFF2-40B4-BE49-F238E27FC236}">
-                <a16:creationId xmlns:a16="http://schemas.microsoft.com/office/drawing/2014/main" id="{DFF53143-BE65-43E7-BCCC-49648209426E}"/>
+                <a16:creationId xmlns:a16="http://schemas.microsoft.com/office/drawing/2014/main" id="{EFE5FE18-E5B0-4E38-B12F-AF396F0A4BE9}"/>
               </a:ext>
             </a:extLst>
           </p:cNvPr>
@@ -15507,7 +15527,7 @@
           <p:cNvPr id="3" name="number">
             <a:extLst xmlns:a="http://schemas.openxmlformats.org/drawingml/2006/main">
               <a:ext uri="{FF2B5EF4-FFF2-40B4-BE49-F238E27FC236}">
-                <a16:creationId xmlns:a16="http://schemas.microsoft.com/office/drawing/2014/main" id="{76856AA2-5503-4BEE-973C-8B9AF6513D6C}"/>
+                <a16:creationId xmlns:a16="http://schemas.microsoft.com/office/drawing/2014/main" id="{47A98524-7393-486C-923D-5D558DEA97A6}"/>
               </a:ext>
             </a:extLst>
           </p:cNvPr>
@@ -15665,7 +15685,7 @@
           <p:cNvPr id="4" name="run-heading">
             <a:extLst xmlns:a="http://schemas.openxmlformats.org/drawingml/2006/main">
               <a:ext uri="{FF2B5EF4-FFF2-40B4-BE49-F238E27FC236}">
-                <a16:creationId xmlns:a16="http://schemas.microsoft.com/office/drawing/2014/main" id="{D35C077F-F4CD-4FFD-BF89-ED9C0C637623}"/>
+                <a16:creationId xmlns:a16="http://schemas.microsoft.com/office/drawing/2014/main" id="{64FE93C6-C6A5-4D91-BB20-B33DACBD62A5}"/>
               </a:ext>
             </a:extLst>
           </p:cNvPr>
@@ -15823,7 +15843,7 @@
           <p:cNvPr id="5" name="run-commands">
             <a:extLst xmlns:a="http://schemas.openxmlformats.org/drawingml/2006/main">
               <a:ext uri="{FF2B5EF4-FFF2-40B4-BE49-F238E27FC236}">
-                <a16:creationId xmlns:a16="http://schemas.microsoft.com/office/drawing/2014/main" id="{7E510553-F803-42CD-AED4-F26E988392F4}"/>
+                <a16:creationId xmlns:a16="http://schemas.microsoft.com/office/drawing/2014/main" id="{EE6C1A0D-9B96-47EC-B939-8687916B303A}"/>
               </a:ext>
             </a:extLst>
           </p:cNvPr>
@@ -16096,7 +16116,7 @@
           <p:cNvPr id="6" name="config-heading">
             <a:extLst xmlns:a="http://schemas.openxmlformats.org/drawingml/2006/main">
               <a:ext uri="{FF2B5EF4-FFF2-40B4-BE49-F238E27FC236}">
-                <a16:creationId xmlns:a16="http://schemas.microsoft.com/office/drawing/2014/main" id="{13DAD373-7CED-42F1-83FA-45F8B7E41593}"/>
+                <a16:creationId xmlns:a16="http://schemas.microsoft.com/office/drawing/2014/main" id="{5214E6EF-6061-4664-A184-BCA5C53680CE}"/>
               </a:ext>
             </a:extLst>
           </p:cNvPr>
@@ -16254,7 +16274,7 @@
           <p:cNvPr id="7" name="config-body">
             <a:extLst xmlns:a="http://schemas.openxmlformats.org/drawingml/2006/main">
               <a:ext uri="{FF2B5EF4-FFF2-40B4-BE49-F238E27FC236}">
-                <a16:creationId xmlns:a16="http://schemas.microsoft.com/office/drawing/2014/main" id="{74A50851-E363-4DE7-90A8-D49320569AB5}"/>
+                <a16:creationId xmlns:a16="http://schemas.microsoft.com/office/drawing/2014/main" id="{03FF455C-7163-4C14-B2F4-3DA20863A941}"/>
               </a:ext>
             </a:extLst>
           </p:cNvPr>
@@ -16402,12 +16422,7 @@
                 <a:ea typeface="Arial"/>
                 <a:cs typeface="Arial"/>
               </a:rPr>
-              <a:t>MYBUD_MODE=demo is the default.</a:t>
-            </a:r>
-          </a:p>
-          <a:p xmlns:a="http://schemas.openxmlformats.org/drawingml/2006/main">
-            <a:r>
-              <a:t/>
+              <a:t>Vercel Django in Singapore.</a:t>
             </a:r>
           </a:p>
           <a:p xmlns:a="http://schemas.openxmlformats.org/drawingml/2006/main">
@@ -16430,7 +16445,7 @@
                 <a:ea typeface="Arial"/>
                 <a:cs typeface="Arial"/>
               </a:rPr>
-              <a:t>For live mode, set GEMINI_API_KEY and GEMINI_MODEL.</a:t>
+              <a:t>Neon PostgreSQL storage.</a:t>
             </a:r>
           </a:p>
           <a:p xmlns:a="http://schemas.openxmlformats.org/drawingml/2006/main">
@@ -16458,7 +16473,63 @@
                 <a:ea typeface="Arial"/>
                 <a:cs typeface="Arial"/>
               </a:rPr>
-              <a:t>Copy .env.example to .env and set deployment values as needed.</a:t>
+              <a:t>MYBUD_MODE=demo.</a:t>
+            </a:r>
+          </a:p>
+          <a:p xmlns:a="http://schemas.openxmlformats.org/drawingml/2006/main">
+            <a:r>
+              <a:t/>
+            </a:r>
+          </a:p>
+          <a:p xmlns:a="http://schemas.openxmlformats.org/drawingml/2006/main">
+            <a:pPr>
+              <a:defRPr sz="1950">
+                <a:solidFill>
+                  <a:srgbClr val="14213D"/>
+                </a:solidFill>
+                <a:latin typeface="Arial"/>
+                <a:ea typeface="Arial"/>
+                <a:cs typeface="Arial"/>
+              </a:defRPr>
+            </a:pPr>
+            <a:r>
+              <a:rPr sz="1950">
+                <a:solidFill>
+                  <a:srgbClr val="14213D"/>
+                </a:solidFill>
+                <a:latin typeface="Arial"/>
+                <a:ea typeface="Arial"/>
+                <a:cs typeface="Arial"/>
+              </a:rPr>
+              <a:t>Local: SQLite with .env settings.</a:t>
+            </a:r>
+          </a:p>
+          <a:p xmlns:a="http://schemas.openxmlformats.org/drawingml/2006/main">
+            <a:r>
+              <a:t/>
+            </a:r>
+          </a:p>
+          <a:p xmlns:a="http://schemas.openxmlformats.org/drawingml/2006/main">
+            <a:pPr>
+              <a:defRPr sz="1950">
+                <a:solidFill>
+                  <a:srgbClr val="14213D"/>
+                </a:solidFill>
+                <a:latin typeface="Arial"/>
+                <a:ea typeface="Arial"/>
+                <a:cs typeface="Arial"/>
+              </a:defRPr>
+            </a:pPr>
+            <a:r>
+              <a:rPr sz="1950">
+                <a:solidFill>
+                  <a:srgbClr val="14213D"/>
+                </a:solidFill>
+                <a:latin typeface="Arial"/>
+                <a:ea typeface="Arial"/>
+                <a:cs typeface="Arial"/>
+              </a:rPr>
+              <a:t>Uploads: hosted 3 MB; local 5 MB.</a:t>
             </a:r>
           </a:p>
         </p:txBody>
@@ -16468,7 +16539,7 @@
           <p:cNvPr id="8" name="run-note">
             <a:extLst xmlns:a="http://schemas.openxmlformats.org/drawingml/2006/main">
               <a:ext uri="{FF2B5EF4-FFF2-40B4-BE49-F238E27FC236}">
-                <a16:creationId xmlns:a16="http://schemas.microsoft.com/office/drawing/2014/main" id="{B5D1C841-C85B-4FFC-85FD-0E42F37F8045}"/>
+                <a16:creationId xmlns:a16="http://schemas.microsoft.com/office/drawing/2014/main" id="{5C57407F-CBCC-42B3-9807-0A024EC475E8}"/>
               </a:ext>
             </a:extLst>
           </p:cNvPr>
@@ -16479,8 +16550,8 @@
         </p:nvSpPr>
         <p:spPr>
           <a:xfrm xmlns:a="http://schemas.openxmlformats.org/drawingml/2006/main">
-            <a:off x="685800" y="5829300"/>
-            <a:ext cx="10820400" cy="514350"/>
+            <a:off x="685800" y="5753100"/>
+            <a:ext cx="10820400" cy="628650"/>
           </a:xfrm>
           <a:prstGeom xmlns:a="http://schemas.openxmlformats.org/drawingml/2006/main" prst="rect">
             <a:avLst/>
@@ -16496,7 +16567,7 @@
           </a:bodyPr>
           <a:lstStyle xmlns:a="http://schemas.openxmlformats.org/drawingml/2006/main">
             <a:defPPr>
-              <a:defRPr sz="1800">
+              <a:defRPr sz="1725">
                 <a:solidFill>
                   <a:srgbClr val="54647B"/>
                 </a:solidFill>
@@ -16506,7 +16577,7 @@
               </a:defRPr>
             </a:defPPr>
             <a:lvl1pPr>
-              <a:defRPr sz="1800">
+              <a:defRPr sz="1725">
                 <a:solidFill>
                   <a:srgbClr val="54647B"/>
                 </a:solidFill>
@@ -16516,7 +16587,7 @@
               </a:defRPr>
             </a:lvl1pPr>
             <a:lvl2pPr>
-              <a:defRPr sz="1800">
+              <a:defRPr sz="1725">
                 <a:solidFill>
                   <a:srgbClr val="54647B"/>
                 </a:solidFill>
@@ -16526,7 +16597,7 @@
               </a:defRPr>
             </a:lvl2pPr>
             <a:lvl3pPr>
-              <a:defRPr sz="1800">
+              <a:defRPr sz="1725">
                 <a:solidFill>
                   <a:srgbClr val="54647B"/>
                 </a:solidFill>
@@ -16536,7 +16607,7 @@
               </a:defRPr>
             </a:lvl3pPr>
             <a:lvl4pPr>
-              <a:defRPr sz="1800">
+              <a:defRPr sz="1725">
                 <a:solidFill>
                   <a:srgbClr val="54647B"/>
                 </a:solidFill>
@@ -16546,7 +16617,7 @@
               </a:defRPr>
             </a:lvl4pPr>
             <a:lvl5pPr>
-              <a:defRPr sz="1800">
+              <a:defRPr sz="1725">
                 <a:solidFill>
                   <a:srgbClr val="54647B"/>
                 </a:solidFill>
@@ -16556,7 +16627,7 @@
               </a:defRPr>
             </a:lvl5pPr>
             <a:lvl6pPr>
-              <a:defRPr sz="1800">
+              <a:defRPr sz="1725">
                 <a:solidFill>
                   <a:srgbClr val="54647B"/>
                 </a:solidFill>
@@ -16566,7 +16637,7 @@
               </a:defRPr>
             </a:lvl6pPr>
             <a:lvl7pPr>
-              <a:defRPr sz="1800">
+              <a:defRPr sz="1725">
                 <a:solidFill>
                   <a:srgbClr val="54647B"/>
                 </a:solidFill>
@@ -16576,7 +16647,7 @@
               </a:defRPr>
             </a:lvl7pPr>
             <a:lvl8pPr>
-              <a:defRPr sz="1800">
+              <a:defRPr sz="1725">
                 <a:solidFill>
                   <a:srgbClr val="54647B"/>
                 </a:solidFill>
@@ -16586,7 +16657,7 @@
               </a:defRPr>
             </a:lvl8pPr>
             <a:lvl9pPr>
-              <a:defRPr sz="1800">
+              <a:defRPr sz="1725">
                 <a:solidFill>
                   <a:srgbClr val="54647B"/>
                 </a:solidFill>
@@ -16598,7 +16669,7 @@
           </a:lstStyle>
           <a:p xmlns:a="http://schemas.openxmlformats.org/drawingml/2006/main">
             <a:pPr>
-              <a:defRPr sz="1800">
+              <a:defRPr sz="1725">
                 <a:solidFill>
                   <a:srgbClr val="54647B"/>
                 </a:solidFill>
@@ -16608,7 +16679,7 @@
               </a:defRPr>
             </a:pPr>
             <a:r>
-              <a:rPr sz="1800">
+              <a:rPr sz="1725">
                 <a:solidFill>
                   <a:srgbClr val="54647B"/>
                 </a:solidFill>
@@ -16616,7 +16687,30 @@
                 <a:ea typeface="Arial"/>
                 <a:cs typeface="Arial"/>
               </a:rPr>
-              <a:t>Follow README.md and .env.example for the complete commands and supported settings.</a:t>
+              <a:t>Demo: https://mybud-student-assistant.vercel.app</a:t>
+            </a:r>
+          </a:p>
+          <a:p xmlns:a="http://schemas.openxmlformats.org/drawingml/2006/main">
+            <a:pPr>
+              <a:defRPr sz="1725">
+                <a:solidFill>
+                  <a:srgbClr val="54647B"/>
+                </a:solidFill>
+                <a:latin typeface="Arial"/>
+                <a:ea typeface="Arial"/>
+                <a:cs typeface="Arial"/>
+              </a:defRPr>
+            </a:pPr>
+            <a:r>
+              <a:rPr sz="1725">
+                <a:solidFill>
+                  <a:srgbClr val="54647B"/>
+                </a:solidFill>
+                <a:latin typeface="Arial"/>
+                <a:ea typeface="Arial"/>
+                <a:cs typeface="Arial"/>
+              </a:rPr>
+              <a:t>Code: https://github.com/BikashCoder31/mybud-student-assistant</a:t>
             </a:r>
           </a:p>
         </p:txBody>
@@ -16624,7 +16718,7 @@
     </p:spTree>
     <p:extLst>
       <p:ext uri="{BB962C8B-B14F-4D97-AF65-F5344CB8AC3E}">
-        <p14:creationId xmlns:p14="http://schemas.microsoft.com/office/powerpoint/2010/main" val="577005241"/>
+        <p14:creationId xmlns:p14="http://schemas.microsoft.com/office/powerpoint/2010/main" val="949814561"/>
       </p:ext>
     </p:extLst>
   </p:cSld>

</xml_diff>